<commit_message>
Clean up: drop planning docs and pitch slide 6
- Remove 10 markdown planning files (01-PLAN..10-DATA-SOURCES). They were
  internal implementation specs, not user-facing.
- Drop pitch deck slide 6 (roadmap + "hackathon zamanı geldi"). 4th-wall
  breaking didn't fit the tone. Deck is now 5 slides.
- Update root README to remove dead links and reflect the 5-slide deck.
</commit_message>
<xml_diff>
--- a/AgentMarket-Pitch.pptx
+++ b/AgentMarket-Pitch.pptx
@@ -10,10 +10,9 @@
     <p:sldId id="258" r:id="rId4"/>
     <p:sldId id="259" r:id="rId5"/>
     <p:sldId id="260" r:id="rId6"/>
-    <p:sldId id="261" r:id="rId7"/>
   </p:sldIdLst>
   <p:notesMasterIdLst>
-    <p:notesMasterId r:id="rId8"/>
+    <p:notesMasterId r:id="rId7"/>
   </p:notesMasterIdLst>
   <p:sldSz cx="12192000" cy="6858000"/>
   <p:notesSz cx="6858000" cy="12192000"/>
@@ -901,94 +900,6 @@
 </p:notes>
 </file>
 
-<file path=ppt/notesSlides/notesSlide6.xml><?xml version="1.0" encoding="utf-8"?>
-<p:notes xmlns:a="http://schemas.openxmlformats.org/drawingml/2006/main" xmlns:r="http://schemas.openxmlformats.org/officeDocument/2006/relationships" xmlns:p="http://schemas.openxmlformats.org/presentationml/2006/main">
-  <p:cSld>
-    <p:spTree>
-      <p:nvGrpSpPr>
-        <p:cNvPr id="1" name=""/>
-        <p:cNvGrpSpPr/>
-        <p:nvPr/>
-      </p:nvGrpSpPr>
-      <p:grpSpPr>
-        <a:xfrm>
-          <a:off x="0" y="0"/>
-          <a:ext cx="0" cy="0"/>
-          <a:chOff x="0" y="0"/>
-          <a:chExt cx="0" cy="0"/>
-        </a:xfrm>
-      </p:grpSpPr>
-      <p:sp>
-        <p:nvSpPr>
-          <p:cNvPr id="2" name="Slide Image Placeholder 1"/>
-          <p:cNvSpPr>
-            <a:spLocks noGrp="1" noRot="1" noChangeAspect="1"/>
-          </p:cNvSpPr>
-          <p:nvPr>
-            <p:ph type="sldImg"/>
-          </p:nvPr>
-        </p:nvSpPr>
-        <p:spPr/>
-      </p:sp>
-      <p:sp>
-        <p:nvSpPr>
-          <p:cNvPr id="3" name="Notes Placeholder 2"/>
-          <p:cNvSpPr>
-            <a:spLocks noGrp="1"/>
-          </p:cNvSpPr>
-          <p:nvPr>
-            <p:ph type="body" idx="1"/>
-          </p:nvPr>
-        </p:nvSpPr>
-        <p:spPr/>
-        <p:txBody>
-          <a:bodyPr/>
-          <a:lstStyle/>
-          <a:p>
-            <a:r>
-              <a:rPr lang="en-US" dirty="0"/>
-              <a:t/>
-            </a:r>
-            <a:endParaRPr lang="en-US" dirty="0"/>
-          </a:p>
-        </p:txBody>
-      </p:sp>
-      <p:sp>
-        <p:nvSpPr>
-          <p:cNvPr id="4" name="Slide Number Placeholder 3"/>
-          <p:cNvSpPr>
-            <a:spLocks noGrp="1"/>
-          </p:cNvSpPr>
-          <p:nvPr>
-            <p:ph type="sldNum" sz="quarter" idx="10"/>
-          </p:nvPr>
-        </p:nvSpPr>
-        <p:spPr/>
-        <p:txBody>
-          <a:bodyPr/>
-          <a:lstStyle/>
-          <a:p>
-            <a:fld id="{F7021451-1387-4CA6-816F-3879F97B5CBC}" type="slidenum">
-              <a:rPr lang="en-US"/>
-              <a:t>6</a:t>
-            </a:fld>
-            <a:endParaRPr lang="en-US"/>
-          </a:p>
-        </p:txBody>
-      </p:sp>
-    </p:spTree>
-    <p:extLst>
-      <p:ext uri="{BB962C8B-B14F-4D97-AF65-F5344CB8AC3E}">
-        <p14:creationId xmlns:p14="http://schemas.microsoft.com/office/powerpoint/2010/main" val="1024086991"/>
-      </p:ext>
-    </p:extLst>
-  </p:cSld>
-  <p:clrMapOvr>
-    <a:masterClrMapping/>
-  </p:clrMapOvr>
-</p:notes>
-</file>
-
 <file path=ppt/slideLayouts/slideLayout1.xml><?xml version="1.0" encoding="utf-8"?>
 <p:sldLayout xmlns:a="http://schemas.openxmlformats.org/drawingml/2006/main" xmlns:r="http://schemas.openxmlformats.org/officeDocument/2006/relationships" xmlns:p="http://schemas.openxmlformats.org/presentationml/2006/main" preserve="1">
   <p:cSld name="DEFAULT">
@@ -1652,7 +1563,7 @@
                 <a:ea typeface="Calibri" pitchFamily="34" charset="-122"/>
                 <a:cs typeface="Calibri" pitchFamily="34" charset="-120"/>
               </a:rPr>
-              <a:t>01 / 6</a:t>
+              <a:t>01 / 5</a:t>
             </a:r>
             <a:endParaRPr lang="en-US" sz="900" dirty="0"/>
           </a:p>
@@ -2453,7 +2364,7 @@
                 <a:ea typeface="Calibri" pitchFamily="34" charset="-122"/>
                 <a:cs typeface="Calibri" pitchFamily="34" charset="-120"/>
               </a:rPr>
-              <a:t>02 / 6</a:t>
+              <a:t>02 / 5</a:t>
             </a:r>
             <a:endParaRPr lang="en-US" sz="900" dirty="0"/>
           </a:p>
@@ -4052,7 +3963,7 @@
                 <a:ea typeface="Calibri" pitchFamily="34" charset="-122"/>
                 <a:cs typeface="Calibri" pitchFamily="34" charset="-120"/>
               </a:rPr>
-              <a:t>03 / 6</a:t>
+              <a:t>03 / 5</a:t>
             </a:r>
             <a:endParaRPr lang="en-US" sz="900" dirty="0"/>
           </a:p>
@@ -4369,7 +4280,7 @@
                 <a:ea typeface="Calibri" pitchFamily="34" charset="-122"/>
                 <a:cs typeface="Calibri" pitchFamily="34" charset="-120"/>
               </a:rPr>
-              <a:t>04 / 6</a:t>
+              <a:t>04 / 5</a:t>
             </a:r>
             <a:endParaRPr lang="en-US" sz="900" dirty="0"/>
           </a:p>
@@ -5376,7 +5287,7 @@
                 <a:ea typeface="Calibri" pitchFamily="34" charset="-122"/>
                 <a:cs typeface="Calibri" pitchFamily="34" charset="-120"/>
               </a:rPr>
-              <a:t>05 / 6</a:t>
+              <a:t>05 / 5</a:t>
             </a:r>
             <a:endParaRPr lang="en-US" sz="900" dirty="0"/>
           </a:p>
@@ -5385,1270 +5296,6 @@
       <p:sp>
         <p:nvSpPr>
           <p:cNvPr id="26" name="Text 20"/>
-          <p:cNvSpPr/>
-          <p:nvPr/>
-        </p:nvSpPr>
-        <p:spPr>
-          <a:xfrm>
-            <a:off x="548640" y="6446520"/>
-            <a:ext cx="1828800" cy="274320"/>
-          </a:xfrm>
-          <a:prstGeom prst="rect">
-            <a:avLst/>
-          </a:prstGeom>
-          <a:noFill/>
-          <a:ln/>
-        </p:spPr>
-        <p:txBody>
-          <a:bodyPr wrap="square" rtlCol="0" anchor="ctr"/>
-          <a:lstStyle/>
-          <a:p>
-            <a:pPr indent="0" marL="0">
-              <a:buNone/>
-            </a:pPr>
-            <a:r>
-              <a:rPr lang="en-US" sz="900" b="1" spc="400" kern="0" dirty="0">
-                <a:solidFill>
-                  <a:srgbClr val="64748B"/>
-                </a:solidFill>
-                <a:latin typeface="Calibri" pitchFamily="34" charset="0"/>
-                <a:ea typeface="Calibri" pitchFamily="34" charset="-122"/>
-                <a:cs typeface="Calibri" pitchFamily="34" charset="-120"/>
-              </a:rPr>
-              <a:t>AGENTMARKET</a:t>
-            </a:r>
-            <a:endParaRPr lang="en-US" sz="900" dirty="0"/>
-          </a:p>
-        </p:txBody>
-      </p:sp>
-    </p:spTree>
-  </p:cSld>
-  <p:clrMapOvr>
-    <a:masterClrMapping/>
-  </p:clrMapOvr>
-</p:sld>
-</file>
-
-<file path=ppt/slides/slide6.xml><?xml version="1.0" encoding="utf-8"?>
-<p:sld xmlns:a="http://schemas.openxmlformats.org/drawingml/2006/main" xmlns:r="http://schemas.openxmlformats.org/officeDocument/2006/relationships" xmlns:p="http://schemas.openxmlformats.org/presentationml/2006/main">
-  <p:cSld name="Slide 6">
-    <p:bg>
-      <p:bgPr>
-        <a:solidFill>
-          <a:srgbClr val="060814"/>
-        </a:solidFill>
-      </p:bgPr>
-    </p:bg>
-    <p:spTree>
-      <p:nvGrpSpPr>
-        <p:cNvPr id="1" name=""/>
-        <p:cNvGrpSpPr/>
-        <p:nvPr/>
-      </p:nvGrpSpPr>
-      <p:grpSpPr>
-        <a:xfrm>
-          <a:off x="0" y="0"/>
-          <a:ext cx="0" cy="0"/>
-          <a:chOff x="0" y="0"/>
-          <a:chExt cx="0" cy="0"/>
-        </a:xfrm>
-      </p:grpSpPr>
-      <p:sp>
-        <p:nvSpPr>
-          <p:cNvPr id="2" name="Shape 0"/>
-          <p:cNvSpPr/>
-          <p:nvPr/>
-        </p:nvSpPr>
-        <p:spPr>
-          <a:xfrm>
-            <a:off x="548640" y="457200"/>
-            <a:ext cx="1828800" cy="329184"/>
-          </a:xfrm>
-          <a:prstGeom prst="roundRect">
-            <a:avLst>
-              <a:gd name="adj" fmla="val 50000"/>
-            </a:avLst>
-          </a:prstGeom>
-          <a:solidFill>
-            <a:srgbClr val="131A2E"/>
-          </a:solidFill>
-          <a:ln w="9525">
-            <a:solidFill>
-              <a:srgbClr val="34D399"/>
-            </a:solidFill>
-            <a:prstDash val="solid"/>
-          </a:ln>
-        </p:spPr>
-      </p:sp>
-      <p:sp>
-        <p:nvSpPr>
-          <p:cNvPr id="3" name="Text 1"/>
-          <p:cNvSpPr/>
-          <p:nvPr/>
-        </p:nvSpPr>
-        <p:spPr>
-          <a:xfrm>
-            <a:off x="548640" y="457200"/>
-            <a:ext cx="1828800" cy="329184"/>
-          </a:xfrm>
-          <a:prstGeom prst="rect">
-            <a:avLst/>
-          </a:prstGeom>
-          <a:noFill/>
-          <a:ln/>
-        </p:spPr>
-        <p:txBody>
-          <a:bodyPr wrap="square" lIns="0" tIns="0" rIns="0" bIns="0" rtlCol="0" anchor="ctr"/>
-          <a:lstStyle/>
-          <a:p>
-            <a:pPr algn="ctr" indent="0" marL="0">
-              <a:buNone/>
-            </a:pPr>
-            <a:r>
-              <a:rPr lang="en-US" sz="1000" b="1" spc="400" kern="0" dirty="0">
-                <a:solidFill>
-                  <a:srgbClr val="34D399"/>
-                </a:solidFill>
-                <a:latin typeface="Calibri" pitchFamily="34" charset="0"/>
-                <a:ea typeface="Calibri" pitchFamily="34" charset="-122"/>
-                <a:cs typeface="Calibri" pitchFamily="34" charset="-120"/>
-              </a:rPr>
-              <a:t>YOL HARİTASI</a:t>
-            </a:r>
-            <a:endParaRPr lang="en-US" sz="1000" dirty="0"/>
-          </a:p>
-        </p:txBody>
-      </p:sp>
-      <p:sp>
-        <p:nvSpPr>
-          <p:cNvPr id="4" name="Text 2"/>
-          <p:cNvSpPr/>
-          <p:nvPr/>
-        </p:nvSpPr>
-        <p:spPr>
-          <a:xfrm>
-            <a:off x="548640" y="914400"/>
-            <a:ext cx="10972800" cy="640080"/>
-          </a:xfrm>
-          <a:prstGeom prst="rect">
-            <a:avLst/>
-          </a:prstGeom>
-          <a:noFill/>
-          <a:ln/>
-        </p:spPr>
-        <p:txBody>
-          <a:bodyPr wrap="square" rtlCol="0" anchor="ctr"/>
-          <a:lstStyle/>
-          <a:p>
-            <a:pPr indent="0" marL="0">
-              <a:buNone/>
-            </a:pPr>
-            <a:r>
-              <a:rPr lang="en-US" sz="3200" b="1" dirty="0">
-                <a:solidFill>
-                  <a:srgbClr val="E6EAF2"/>
-                </a:solidFill>
-                <a:latin typeface="Calibri" pitchFamily="34" charset="0"/>
-                <a:ea typeface="Calibri" pitchFamily="34" charset="-122"/>
-                <a:cs typeface="Calibri" pitchFamily="34" charset="-120"/>
-              </a:rPr>
-              <a:t>Hackathon'dan ürüne</a:t>
-            </a:r>
-            <a:endParaRPr lang="en-US" sz="3200" dirty="0"/>
-          </a:p>
-        </p:txBody>
-      </p:sp>
-      <p:sp>
-        <p:nvSpPr>
-          <p:cNvPr id="5" name="Shape 3"/>
-          <p:cNvSpPr/>
-          <p:nvPr/>
-        </p:nvSpPr>
-        <p:spPr>
-          <a:xfrm>
-            <a:off x="1143000" y="2514600"/>
-            <a:ext cx="10241280" cy="0"/>
-          </a:xfrm>
-          <a:prstGeom prst="line">
-            <a:avLst/>
-          </a:prstGeom>
-          <a:noFill/>
-          <a:ln w="19050">
-            <a:solidFill>
-              <a:srgbClr val="1E293B"/>
-            </a:solidFill>
-            <a:prstDash val="solid"/>
-          </a:ln>
-        </p:spPr>
-      </p:sp>
-      <p:sp>
-        <p:nvSpPr>
-          <p:cNvPr id="6" name="Shape 4"/>
-          <p:cNvSpPr/>
-          <p:nvPr/>
-        </p:nvSpPr>
-        <p:spPr>
-          <a:xfrm>
-            <a:off x="1325880" y="2148840"/>
-            <a:ext cx="731520" cy="731520"/>
-          </a:xfrm>
-          <a:prstGeom prst="ellipse">
-            <a:avLst/>
-          </a:prstGeom>
-          <a:solidFill>
-            <a:srgbClr val="131A2E"/>
-          </a:solidFill>
-          <a:ln w="19050">
-            <a:solidFill>
-              <a:srgbClr val="34D399"/>
-            </a:solidFill>
-            <a:prstDash val="solid"/>
-          </a:ln>
-        </p:spPr>
-      </p:sp>
-      <p:sp>
-        <p:nvSpPr>
-          <p:cNvPr id="7" name="Text 5"/>
-          <p:cNvSpPr/>
-          <p:nvPr/>
-        </p:nvSpPr>
-        <p:spPr>
-          <a:xfrm>
-            <a:off x="1325880" y="2148840"/>
-            <a:ext cx="731520" cy="731520"/>
-          </a:xfrm>
-          <a:prstGeom prst="rect">
-            <a:avLst/>
-          </a:prstGeom>
-          <a:noFill/>
-          <a:ln/>
-        </p:spPr>
-        <p:txBody>
-          <a:bodyPr wrap="square" rtlCol="0" anchor="ctr"/>
-          <a:lstStyle/>
-          <a:p>
-            <a:pPr algn="ctr" indent="0" marL="0">
-              <a:buNone/>
-            </a:pPr>
-            <a:r>
-              <a:rPr lang="en-US" sz="2200" b="1" dirty="0">
-                <a:solidFill>
-                  <a:srgbClr val="34D399"/>
-                </a:solidFill>
-                <a:latin typeface="Calibri" pitchFamily="34" charset="0"/>
-                <a:ea typeface="Calibri" pitchFamily="34" charset="-122"/>
-                <a:cs typeface="Calibri" pitchFamily="34" charset="-120"/>
-              </a:rPr>
-              <a:t>1</a:t>
-            </a:r>
-            <a:endParaRPr lang="en-US" sz="2200" dirty="0"/>
-          </a:p>
-        </p:txBody>
-      </p:sp>
-      <p:sp>
-        <p:nvSpPr>
-          <p:cNvPr id="8" name="Text 6"/>
-          <p:cNvSpPr/>
-          <p:nvPr/>
-        </p:nvSpPr>
-        <p:spPr>
-          <a:xfrm>
-            <a:off x="594360" y="3063240"/>
-            <a:ext cx="2194560" cy="274320"/>
-          </a:xfrm>
-          <a:prstGeom prst="rect">
-            <a:avLst/>
-          </a:prstGeom>
-          <a:noFill/>
-          <a:ln/>
-        </p:spPr>
-        <p:txBody>
-          <a:bodyPr wrap="square" rtlCol="0" anchor="ctr"/>
-          <a:lstStyle/>
-          <a:p>
-            <a:pPr algn="ctr" indent="0" marL="0">
-              <a:buNone/>
-            </a:pPr>
-            <a:r>
-              <a:rPr lang="en-US" sz="1000" b="1" spc="400" kern="0" dirty="0">
-                <a:solidFill>
-                  <a:srgbClr val="34D399"/>
-                </a:solidFill>
-                <a:latin typeface="Calibri" pitchFamily="34" charset="0"/>
-                <a:ea typeface="Calibri" pitchFamily="34" charset="-122"/>
-                <a:cs typeface="Calibri" pitchFamily="34" charset="-120"/>
-              </a:rPr>
-              <a:t>ŞİMDİ</a:t>
-            </a:r>
-            <a:endParaRPr lang="en-US" sz="1000" dirty="0"/>
-          </a:p>
-        </p:txBody>
-      </p:sp>
-      <p:sp>
-        <p:nvSpPr>
-          <p:cNvPr id="9" name="Text 7"/>
-          <p:cNvSpPr/>
-          <p:nvPr/>
-        </p:nvSpPr>
-        <p:spPr>
-          <a:xfrm>
-            <a:off x="594360" y="3383280"/>
-            <a:ext cx="2194560" cy="457200"/>
-          </a:xfrm>
-          <a:prstGeom prst="rect">
-            <a:avLst/>
-          </a:prstGeom>
-          <a:noFill/>
-          <a:ln/>
-        </p:spPr>
-        <p:txBody>
-          <a:bodyPr wrap="square" rtlCol="0" anchor="ctr"/>
-          <a:lstStyle/>
-          <a:p>
-            <a:pPr algn="ctr" indent="0" marL="0">
-              <a:buNone/>
-            </a:pPr>
-            <a:r>
-              <a:rPr lang="en-US" sz="1500" b="1" dirty="0">
-                <a:solidFill>
-                  <a:srgbClr val="E6EAF2"/>
-                </a:solidFill>
-                <a:latin typeface="Calibri" pitchFamily="34" charset="0"/>
-                <a:ea typeface="Calibri" pitchFamily="34" charset="-122"/>
-                <a:cs typeface="Calibri" pitchFamily="34" charset="-120"/>
-              </a:rPr>
-              <a:t>Hackathon MVP</a:t>
-            </a:r>
-            <a:endParaRPr lang="en-US" sz="1500" dirty="0"/>
-          </a:p>
-        </p:txBody>
-      </p:sp>
-      <p:sp>
-        <p:nvSpPr>
-          <p:cNvPr id="10" name="Text 8"/>
-          <p:cNvSpPr/>
-          <p:nvPr/>
-        </p:nvSpPr>
-        <p:spPr>
-          <a:xfrm>
-            <a:off x="685800" y="3886200"/>
-            <a:ext cx="2011680" cy="640080"/>
-          </a:xfrm>
-          <a:prstGeom prst="rect">
-            <a:avLst/>
-          </a:prstGeom>
-          <a:noFill/>
-          <a:ln/>
-        </p:spPr>
-        <p:txBody>
-          <a:bodyPr wrap="square" rtlCol="0" anchor="t"/>
-          <a:lstStyle/>
-          <a:p>
-            <a:pPr algn="ctr" indent="0" marL="0">
-              <a:buNone/>
-            </a:pPr>
-            <a:r>
-              <a:rPr lang="en-US" sz="1100" dirty="0">
-                <a:solidFill>
-                  <a:srgbClr val="94A3B8"/>
-                </a:solidFill>
-                <a:latin typeface="Calibri" pitchFamily="34" charset="0"/>
-                <a:ea typeface="Calibri" pitchFamily="34" charset="-122"/>
-                <a:cs typeface="Calibri" pitchFamily="34" charset="-120"/>
-              </a:rPr>
-              <a:t>4 ajan + sandbox + canlı UI</a:t>
-            </a:r>
-            <a:endParaRPr lang="en-US" sz="1100" dirty="0"/>
-          </a:p>
-        </p:txBody>
-      </p:sp>
-      <p:sp>
-        <p:nvSpPr>
-          <p:cNvPr id="11" name="Shape 9"/>
-          <p:cNvSpPr/>
-          <p:nvPr/>
-        </p:nvSpPr>
-        <p:spPr>
-          <a:xfrm>
-            <a:off x="3611880" y="2148840"/>
-            <a:ext cx="731520" cy="731520"/>
-          </a:xfrm>
-          <a:prstGeom prst="ellipse">
-            <a:avLst/>
-          </a:prstGeom>
-          <a:solidFill>
-            <a:srgbClr val="131A2E"/>
-          </a:solidFill>
-          <a:ln w="19050">
-            <a:solidFill>
-              <a:srgbClr val="38BDF8"/>
-            </a:solidFill>
-            <a:prstDash val="solid"/>
-          </a:ln>
-        </p:spPr>
-      </p:sp>
-      <p:sp>
-        <p:nvSpPr>
-          <p:cNvPr id="12" name="Text 10"/>
-          <p:cNvSpPr/>
-          <p:nvPr/>
-        </p:nvSpPr>
-        <p:spPr>
-          <a:xfrm>
-            <a:off x="3611880" y="2148840"/>
-            <a:ext cx="731520" cy="731520"/>
-          </a:xfrm>
-          <a:prstGeom prst="rect">
-            <a:avLst/>
-          </a:prstGeom>
-          <a:noFill/>
-          <a:ln/>
-        </p:spPr>
-        <p:txBody>
-          <a:bodyPr wrap="square" rtlCol="0" anchor="ctr"/>
-          <a:lstStyle/>
-          <a:p>
-            <a:pPr algn="ctr" indent="0" marL="0">
-              <a:buNone/>
-            </a:pPr>
-            <a:r>
-              <a:rPr lang="en-US" sz="2200" b="1" dirty="0">
-                <a:solidFill>
-                  <a:srgbClr val="38BDF8"/>
-                </a:solidFill>
-                <a:latin typeface="Calibri" pitchFamily="34" charset="0"/>
-                <a:ea typeface="Calibri" pitchFamily="34" charset="-122"/>
-                <a:cs typeface="Calibri" pitchFamily="34" charset="-120"/>
-              </a:rPr>
-              <a:t>2</a:t>
-            </a:r>
-            <a:endParaRPr lang="en-US" sz="2200" dirty="0"/>
-          </a:p>
-        </p:txBody>
-      </p:sp>
-      <p:sp>
-        <p:nvSpPr>
-          <p:cNvPr id="13" name="Text 11"/>
-          <p:cNvSpPr/>
-          <p:nvPr/>
-        </p:nvSpPr>
-        <p:spPr>
-          <a:xfrm>
-            <a:off x="2880360" y="3063240"/>
-            <a:ext cx="2194560" cy="274320"/>
-          </a:xfrm>
-          <a:prstGeom prst="rect">
-            <a:avLst/>
-          </a:prstGeom>
-          <a:noFill/>
-          <a:ln/>
-        </p:spPr>
-        <p:txBody>
-          <a:bodyPr wrap="square" rtlCol="0" anchor="ctr"/>
-          <a:lstStyle/>
-          <a:p>
-            <a:pPr algn="ctr" indent="0" marL="0">
-              <a:buNone/>
-            </a:pPr>
-            <a:r>
-              <a:rPr lang="en-US" sz="1000" b="1" spc="400" kern="0" dirty="0">
-                <a:solidFill>
-                  <a:srgbClr val="38BDF8"/>
-                </a:solidFill>
-                <a:latin typeface="Calibri" pitchFamily="34" charset="0"/>
-                <a:ea typeface="Calibri" pitchFamily="34" charset="-122"/>
-                <a:cs typeface="Calibri" pitchFamily="34" charset="-120"/>
-              </a:rPr>
-              <a:t>1 AY</a:t>
-            </a:r>
-            <a:endParaRPr lang="en-US" sz="1000" dirty="0"/>
-          </a:p>
-        </p:txBody>
-      </p:sp>
-      <p:sp>
-        <p:nvSpPr>
-          <p:cNvPr id="14" name="Text 12"/>
-          <p:cNvSpPr/>
-          <p:nvPr/>
-        </p:nvSpPr>
-        <p:spPr>
-          <a:xfrm>
-            <a:off x="2880360" y="3383280"/>
-            <a:ext cx="2194560" cy="457200"/>
-          </a:xfrm>
-          <a:prstGeom prst="rect">
-            <a:avLst/>
-          </a:prstGeom>
-          <a:noFill/>
-          <a:ln/>
-        </p:spPr>
-        <p:txBody>
-          <a:bodyPr wrap="square" rtlCol="0" anchor="ctr"/>
-          <a:lstStyle/>
-          <a:p>
-            <a:pPr algn="ctr" indent="0" marL="0">
-              <a:buNone/>
-            </a:pPr>
-            <a:r>
-              <a:rPr lang="en-US" sz="1500" b="1" dirty="0">
-                <a:solidFill>
-                  <a:srgbClr val="E6EAF2"/>
-                </a:solidFill>
-                <a:latin typeface="Calibri" pitchFamily="34" charset="0"/>
-                <a:ea typeface="Calibri" pitchFamily="34" charset="-122"/>
-                <a:cs typeface="Calibri" pitchFamily="34" charset="-120"/>
-              </a:rPr>
-              <a:t>Browser Extension</a:t>
-            </a:r>
-            <a:endParaRPr lang="en-US" sz="1500" dirty="0"/>
-          </a:p>
-        </p:txBody>
-      </p:sp>
-      <p:sp>
-        <p:nvSpPr>
-          <p:cNvPr id="15" name="Text 13"/>
-          <p:cNvSpPr/>
-          <p:nvPr/>
-        </p:nvSpPr>
-        <p:spPr>
-          <a:xfrm>
-            <a:off x="2971800" y="3886200"/>
-            <a:ext cx="2011680" cy="640080"/>
-          </a:xfrm>
-          <a:prstGeom prst="rect">
-            <a:avLst/>
-          </a:prstGeom>
-          <a:noFill/>
-          <a:ln/>
-        </p:spPr>
-        <p:txBody>
-          <a:bodyPr wrap="square" rtlCol="0" anchor="t"/>
-          <a:lstStyle/>
-          <a:p>
-            <a:pPr algn="ctr" indent="0" marL="0">
-              <a:buNone/>
-            </a:pPr>
-            <a:r>
-              <a:rPr lang="en-US" sz="1100" dirty="0">
-                <a:solidFill>
-                  <a:srgbClr val="94A3B8"/>
-                </a:solidFill>
-                <a:latin typeface="Calibri" pitchFamily="34" charset="0"/>
-                <a:ea typeface="Calibri" pitchFamily="34" charset="-122"/>
-                <a:cs typeface="Calibri" pitchFamily="34" charset="-120"/>
-              </a:rPr>
-              <a:t>Chrome + Edge</a:t>
-            </a:r>
-            <a:endParaRPr lang="en-US" sz="1100" dirty="0"/>
-          </a:p>
-        </p:txBody>
-      </p:sp>
-      <p:sp>
-        <p:nvSpPr>
-          <p:cNvPr id="16" name="Shape 14"/>
-          <p:cNvSpPr/>
-          <p:nvPr/>
-        </p:nvSpPr>
-        <p:spPr>
-          <a:xfrm>
-            <a:off x="5897880" y="2148840"/>
-            <a:ext cx="731520" cy="731520"/>
-          </a:xfrm>
-          <a:prstGeom prst="ellipse">
-            <a:avLst/>
-          </a:prstGeom>
-          <a:solidFill>
-            <a:srgbClr val="131A2E"/>
-          </a:solidFill>
-          <a:ln w="19050">
-            <a:solidFill>
-              <a:srgbClr val="A78BFA"/>
-            </a:solidFill>
-            <a:prstDash val="solid"/>
-          </a:ln>
-        </p:spPr>
-      </p:sp>
-      <p:sp>
-        <p:nvSpPr>
-          <p:cNvPr id="17" name="Text 15"/>
-          <p:cNvSpPr/>
-          <p:nvPr/>
-        </p:nvSpPr>
-        <p:spPr>
-          <a:xfrm>
-            <a:off x="5897880" y="2148840"/>
-            <a:ext cx="731520" cy="731520"/>
-          </a:xfrm>
-          <a:prstGeom prst="rect">
-            <a:avLst/>
-          </a:prstGeom>
-          <a:noFill/>
-          <a:ln/>
-        </p:spPr>
-        <p:txBody>
-          <a:bodyPr wrap="square" rtlCol="0" anchor="ctr"/>
-          <a:lstStyle/>
-          <a:p>
-            <a:pPr algn="ctr" indent="0" marL="0">
-              <a:buNone/>
-            </a:pPr>
-            <a:r>
-              <a:rPr lang="en-US" sz="2200" b="1" dirty="0">
-                <a:solidFill>
-                  <a:srgbClr val="A78BFA"/>
-                </a:solidFill>
-                <a:latin typeface="Calibri" pitchFamily="34" charset="0"/>
-                <a:ea typeface="Calibri" pitchFamily="34" charset="-122"/>
-                <a:cs typeface="Calibri" pitchFamily="34" charset="-120"/>
-              </a:rPr>
-              <a:t>3</a:t>
-            </a:r>
-            <a:endParaRPr lang="en-US" sz="2200" dirty="0"/>
-          </a:p>
-        </p:txBody>
-      </p:sp>
-      <p:sp>
-        <p:nvSpPr>
-          <p:cNvPr id="18" name="Text 16"/>
-          <p:cNvSpPr/>
-          <p:nvPr/>
-        </p:nvSpPr>
-        <p:spPr>
-          <a:xfrm>
-            <a:off x="5166360" y="3063240"/>
-            <a:ext cx="2194560" cy="274320"/>
-          </a:xfrm>
-          <a:prstGeom prst="rect">
-            <a:avLst/>
-          </a:prstGeom>
-          <a:noFill/>
-          <a:ln/>
-        </p:spPr>
-        <p:txBody>
-          <a:bodyPr wrap="square" rtlCol="0" anchor="ctr"/>
-          <a:lstStyle/>
-          <a:p>
-            <a:pPr algn="ctr" indent="0" marL="0">
-              <a:buNone/>
-            </a:pPr>
-            <a:r>
-              <a:rPr lang="en-US" sz="1000" b="1" spc="400" kern="0" dirty="0">
-                <a:solidFill>
-                  <a:srgbClr val="A78BFA"/>
-                </a:solidFill>
-                <a:latin typeface="Calibri" pitchFamily="34" charset="0"/>
-                <a:ea typeface="Calibri" pitchFamily="34" charset="-122"/>
-                <a:cs typeface="Calibri" pitchFamily="34" charset="-120"/>
-              </a:rPr>
-              <a:t>3 AY</a:t>
-            </a:r>
-            <a:endParaRPr lang="en-US" sz="1000" dirty="0"/>
-          </a:p>
-        </p:txBody>
-      </p:sp>
-      <p:sp>
-        <p:nvSpPr>
-          <p:cNvPr id="19" name="Text 17"/>
-          <p:cNvSpPr/>
-          <p:nvPr/>
-        </p:nvSpPr>
-        <p:spPr>
-          <a:xfrm>
-            <a:off x="5166360" y="3383280"/>
-            <a:ext cx="2194560" cy="457200"/>
-          </a:xfrm>
-          <a:prstGeom prst="rect">
-            <a:avLst/>
-          </a:prstGeom>
-          <a:noFill/>
-          <a:ln/>
-        </p:spPr>
-        <p:txBody>
-          <a:bodyPr wrap="square" rtlCol="0" anchor="ctr"/>
-          <a:lstStyle/>
-          <a:p>
-            <a:pPr algn="ctr" indent="0" marL="0">
-              <a:buNone/>
-            </a:pPr>
-            <a:r>
-              <a:rPr lang="en-US" sz="1500" b="1" dirty="0">
-                <a:solidFill>
-                  <a:srgbClr val="E6EAF2"/>
-                </a:solidFill>
-                <a:latin typeface="Calibri" pitchFamily="34" charset="0"/>
-                <a:ea typeface="Calibri" pitchFamily="34" charset="-122"/>
-                <a:cs typeface="Calibri" pitchFamily="34" charset="-120"/>
-              </a:rPr>
-              <a:t>Partner Pilotu</a:t>
-            </a:r>
-            <a:endParaRPr lang="en-US" sz="1500" dirty="0"/>
-          </a:p>
-        </p:txBody>
-      </p:sp>
-      <p:sp>
-        <p:nvSpPr>
-          <p:cNvPr id="20" name="Text 18"/>
-          <p:cNvSpPr/>
-          <p:nvPr/>
-        </p:nvSpPr>
-        <p:spPr>
-          <a:xfrm>
-            <a:off x="5257800" y="3886200"/>
-            <a:ext cx="2011680" cy="640080"/>
-          </a:xfrm>
-          <a:prstGeom prst="rect">
-            <a:avLst/>
-          </a:prstGeom>
-          <a:noFill/>
-          <a:ln/>
-        </p:spPr>
-        <p:txBody>
-          <a:bodyPr wrap="square" rtlCol="0" anchor="t"/>
-          <a:lstStyle/>
-          <a:p>
-            <a:pPr algn="ctr" indent="0" marL="0">
-              <a:buNone/>
-            </a:pPr>
-            <a:r>
-              <a:rPr lang="en-US" sz="1100" dirty="0">
-                <a:solidFill>
-                  <a:srgbClr val="94A3B8"/>
-                </a:solidFill>
-                <a:latin typeface="Calibri" pitchFamily="34" charset="0"/>
-                <a:ea typeface="Calibri" pitchFamily="34" charset="-122"/>
-                <a:cs typeface="Calibri" pitchFamily="34" charset="-120"/>
-              </a:rPr>
-              <a:t>Trendyol / Hepsiburada</a:t>
-            </a:r>
-            <a:endParaRPr lang="en-US" sz="1100" dirty="0"/>
-          </a:p>
-        </p:txBody>
-      </p:sp>
-      <p:sp>
-        <p:nvSpPr>
-          <p:cNvPr id="21" name="Shape 19"/>
-          <p:cNvSpPr/>
-          <p:nvPr/>
-        </p:nvSpPr>
-        <p:spPr>
-          <a:xfrm>
-            <a:off x="8183880" y="2148840"/>
-            <a:ext cx="731520" cy="731520"/>
-          </a:xfrm>
-          <a:prstGeom prst="ellipse">
-            <a:avLst/>
-          </a:prstGeom>
-          <a:solidFill>
-            <a:srgbClr val="131A2E"/>
-          </a:solidFill>
-          <a:ln w="19050">
-            <a:solidFill>
-              <a:srgbClr val="FBBF24"/>
-            </a:solidFill>
-            <a:prstDash val="solid"/>
-          </a:ln>
-        </p:spPr>
-      </p:sp>
-      <p:sp>
-        <p:nvSpPr>
-          <p:cNvPr id="22" name="Text 20"/>
-          <p:cNvSpPr/>
-          <p:nvPr/>
-        </p:nvSpPr>
-        <p:spPr>
-          <a:xfrm>
-            <a:off x="8183880" y="2148840"/>
-            <a:ext cx="731520" cy="731520"/>
-          </a:xfrm>
-          <a:prstGeom prst="rect">
-            <a:avLst/>
-          </a:prstGeom>
-          <a:noFill/>
-          <a:ln/>
-        </p:spPr>
-        <p:txBody>
-          <a:bodyPr wrap="square" rtlCol="0" anchor="ctr"/>
-          <a:lstStyle/>
-          <a:p>
-            <a:pPr algn="ctr" indent="0" marL="0">
-              <a:buNone/>
-            </a:pPr>
-            <a:r>
-              <a:rPr lang="en-US" sz="2200" b="1" dirty="0">
-                <a:solidFill>
-                  <a:srgbClr val="FBBF24"/>
-                </a:solidFill>
-                <a:latin typeface="Calibri" pitchFamily="34" charset="0"/>
-                <a:ea typeface="Calibri" pitchFamily="34" charset="-122"/>
-                <a:cs typeface="Calibri" pitchFamily="34" charset="-120"/>
-              </a:rPr>
-              <a:t>4</a:t>
-            </a:r>
-            <a:endParaRPr lang="en-US" sz="2200" dirty="0"/>
-          </a:p>
-        </p:txBody>
-      </p:sp>
-      <p:sp>
-        <p:nvSpPr>
-          <p:cNvPr id="23" name="Text 21"/>
-          <p:cNvSpPr/>
-          <p:nvPr/>
-        </p:nvSpPr>
-        <p:spPr>
-          <a:xfrm>
-            <a:off x="7452360" y="3063240"/>
-            <a:ext cx="2194560" cy="274320"/>
-          </a:xfrm>
-          <a:prstGeom prst="rect">
-            <a:avLst/>
-          </a:prstGeom>
-          <a:noFill/>
-          <a:ln/>
-        </p:spPr>
-        <p:txBody>
-          <a:bodyPr wrap="square" rtlCol="0" anchor="ctr"/>
-          <a:lstStyle/>
-          <a:p>
-            <a:pPr algn="ctr" indent="0" marL="0">
-              <a:buNone/>
-            </a:pPr>
-            <a:r>
-              <a:rPr lang="en-US" sz="1000" b="1" spc="400" kern="0" dirty="0">
-                <a:solidFill>
-                  <a:srgbClr val="FBBF24"/>
-                </a:solidFill>
-                <a:latin typeface="Calibri" pitchFamily="34" charset="0"/>
-                <a:ea typeface="Calibri" pitchFamily="34" charset="-122"/>
-                <a:cs typeface="Calibri" pitchFamily="34" charset="-120"/>
-              </a:rPr>
-              <a:t>6 AY</a:t>
-            </a:r>
-            <a:endParaRPr lang="en-US" sz="1000" dirty="0"/>
-          </a:p>
-        </p:txBody>
-      </p:sp>
-      <p:sp>
-        <p:nvSpPr>
-          <p:cNvPr id="24" name="Text 22"/>
-          <p:cNvSpPr/>
-          <p:nvPr/>
-        </p:nvSpPr>
-        <p:spPr>
-          <a:xfrm>
-            <a:off x="7452360" y="3383280"/>
-            <a:ext cx="2194560" cy="457200"/>
-          </a:xfrm>
-          <a:prstGeom prst="rect">
-            <a:avLst/>
-          </a:prstGeom>
-          <a:noFill/>
-          <a:ln/>
-        </p:spPr>
-        <p:txBody>
-          <a:bodyPr wrap="square" rtlCol="0" anchor="ctr"/>
-          <a:lstStyle/>
-          <a:p>
-            <a:pPr algn="ctr" indent="0" marL="0">
-              <a:buNone/>
-            </a:pPr>
-            <a:r>
-              <a:rPr lang="en-US" sz="1500" b="1" dirty="0">
-                <a:solidFill>
-                  <a:srgbClr val="E6EAF2"/>
-                </a:solidFill>
-                <a:latin typeface="Calibri" pitchFamily="34" charset="0"/>
-                <a:ea typeface="Calibri" pitchFamily="34" charset="-122"/>
-                <a:cs typeface="Calibri" pitchFamily="34" charset="-120"/>
-              </a:rPr>
-              <a:t>Mobil + B2B</a:t>
-            </a:r>
-            <a:endParaRPr lang="en-US" sz="1500" dirty="0"/>
-          </a:p>
-        </p:txBody>
-      </p:sp>
-      <p:sp>
-        <p:nvSpPr>
-          <p:cNvPr id="25" name="Text 23"/>
-          <p:cNvSpPr/>
-          <p:nvPr/>
-        </p:nvSpPr>
-        <p:spPr>
-          <a:xfrm>
-            <a:off x="7543800" y="3886200"/>
-            <a:ext cx="2011680" cy="640080"/>
-          </a:xfrm>
-          <a:prstGeom prst="rect">
-            <a:avLst/>
-          </a:prstGeom>
-          <a:noFill/>
-          <a:ln/>
-        </p:spPr>
-        <p:txBody>
-          <a:bodyPr wrap="square" rtlCol="0" anchor="t"/>
-          <a:lstStyle/>
-          <a:p>
-            <a:pPr algn="ctr" indent="0" marL="0">
-              <a:buNone/>
-            </a:pPr>
-            <a:r>
-              <a:rPr lang="en-US" sz="1100" dirty="0">
-                <a:solidFill>
-                  <a:srgbClr val="94A3B8"/>
-                </a:solidFill>
-                <a:latin typeface="Calibri" pitchFamily="34" charset="0"/>
-                <a:ea typeface="Calibri" pitchFamily="34" charset="-122"/>
-                <a:cs typeface="Calibri" pitchFamily="34" charset="-120"/>
-              </a:rPr>
-              <a:t>Satıcı tarafı sürümü</a:t>
-            </a:r>
-            <a:endParaRPr lang="en-US" sz="1100" dirty="0"/>
-          </a:p>
-        </p:txBody>
-      </p:sp>
-      <p:sp>
-        <p:nvSpPr>
-          <p:cNvPr id="26" name="Shape 24"/>
-          <p:cNvSpPr/>
-          <p:nvPr/>
-        </p:nvSpPr>
-        <p:spPr>
-          <a:xfrm>
-            <a:off x="10469880" y="2148840"/>
-            <a:ext cx="731520" cy="731520"/>
-          </a:xfrm>
-          <a:prstGeom prst="ellipse">
-            <a:avLst/>
-          </a:prstGeom>
-          <a:solidFill>
-            <a:srgbClr val="131A2E"/>
-          </a:solidFill>
-          <a:ln w="19050">
-            <a:solidFill>
-              <a:srgbClr val="F87171"/>
-            </a:solidFill>
-            <a:prstDash val="solid"/>
-          </a:ln>
-        </p:spPr>
-      </p:sp>
-      <p:sp>
-        <p:nvSpPr>
-          <p:cNvPr id="27" name="Text 25"/>
-          <p:cNvSpPr/>
-          <p:nvPr/>
-        </p:nvSpPr>
-        <p:spPr>
-          <a:xfrm>
-            <a:off x="10469880" y="2148840"/>
-            <a:ext cx="731520" cy="731520"/>
-          </a:xfrm>
-          <a:prstGeom prst="rect">
-            <a:avLst/>
-          </a:prstGeom>
-          <a:noFill/>
-          <a:ln/>
-        </p:spPr>
-        <p:txBody>
-          <a:bodyPr wrap="square" rtlCol="0" anchor="ctr"/>
-          <a:lstStyle/>
-          <a:p>
-            <a:pPr algn="ctr" indent="0" marL="0">
-              <a:buNone/>
-            </a:pPr>
-            <a:r>
-              <a:rPr lang="en-US" sz="2200" b="1" dirty="0">
-                <a:solidFill>
-                  <a:srgbClr val="F87171"/>
-                </a:solidFill>
-                <a:latin typeface="Calibri" pitchFamily="34" charset="0"/>
-                <a:ea typeface="Calibri" pitchFamily="34" charset="-122"/>
-                <a:cs typeface="Calibri" pitchFamily="34" charset="-120"/>
-              </a:rPr>
-              <a:t>5</a:t>
-            </a:r>
-            <a:endParaRPr lang="en-US" sz="2200" dirty="0"/>
-          </a:p>
-        </p:txBody>
-      </p:sp>
-      <p:sp>
-        <p:nvSpPr>
-          <p:cNvPr id="28" name="Text 26"/>
-          <p:cNvSpPr/>
-          <p:nvPr/>
-        </p:nvSpPr>
-        <p:spPr>
-          <a:xfrm>
-            <a:off x="9738360" y="3063240"/>
-            <a:ext cx="2194560" cy="274320"/>
-          </a:xfrm>
-          <a:prstGeom prst="rect">
-            <a:avLst/>
-          </a:prstGeom>
-          <a:noFill/>
-          <a:ln/>
-        </p:spPr>
-        <p:txBody>
-          <a:bodyPr wrap="square" rtlCol="0" anchor="ctr"/>
-          <a:lstStyle/>
-          <a:p>
-            <a:pPr algn="ctr" indent="0" marL="0">
-              <a:buNone/>
-            </a:pPr>
-            <a:r>
-              <a:rPr lang="en-US" sz="1000" b="1" spc="400" kern="0" dirty="0">
-                <a:solidFill>
-                  <a:srgbClr val="F87171"/>
-                </a:solidFill>
-                <a:latin typeface="Calibri" pitchFamily="34" charset="0"/>
-                <a:ea typeface="Calibri" pitchFamily="34" charset="-122"/>
-                <a:cs typeface="Calibri" pitchFamily="34" charset="-120"/>
-              </a:rPr>
-              <a:t>1 YIL</a:t>
-            </a:r>
-            <a:endParaRPr lang="en-US" sz="1000" dirty="0"/>
-          </a:p>
-        </p:txBody>
-      </p:sp>
-      <p:sp>
-        <p:nvSpPr>
-          <p:cNvPr id="29" name="Text 27"/>
-          <p:cNvSpPr/>
-          <p:nvPr/>
-        </p:nvSpPr>
-        <p:spPr>
-          <a:xfrm>
-            <a:off x="9738360" y="3383280"/>
-            <a:ext cx="2194560" cy="457200"/>
-          </a:xfrm>
-          <a:prstGeom prst="rect">
-            <a:avLst/>
-          </a:prstGeom>
-          <a:noFill/>
-          <a:ln/>
-        </p:spPr>
-        <p:txBody>
-          <a:bodyPr wrap="square" rtlCol="0" anchor="ctr"/>
-          <a:lstStyle/>
-          <a:p>
-            <a:pPr algn="ctr" indent="0" marL="0">
-              <a:buNone/>
-            </a:pPr>
-            <a:r>
-              <a:rPr lang="en-US" sz="1500" b="1" dirty="0">
-                <a:solidFill>
-                  <a:srgbClr val="E6EAF2"/>
-                </a:solidFill>
-                <a:latin typeface="Calibri" pitchFamily="34" charset="0"/>
-                <a:ea typeface="Calibri" pitchFamily="34" charset="-122"/>
-                <a:cs typeface="Calibri" pitchFamily="34" charset="-120"/>
-              </a:rPr>
-              <a:t>AI Alışveriş Katmanı</a:t>
-            </a:r>
-            <a:endParaRPr lang="en-US" sz="1500" dirty="0"/>
-          </a:p>
-        </p:txBody>
-      </p:sp>
-      <p:sp>
-        <p:nvSpPr>
-          <p:cNvPr id="30" name="Text 28"/>
-          <p:cNvSpPr/>
-          <p:nvPr/>
-        </p:nvSpPr>
-        <p:spPr>
-          <a:xfrm>
-            <a:off x="9829800" y="3886200"/>
-            <a:ext cx="2011680" cy="640080"/>
-          </a:xfrm>
-          <a:prstGeom prst="rect">
-            <a:avLst/>
-          </a:prstGeom>
-          <a:noFill/>
-          <a:ln/>
-        </p:spPr>
-        <p:txBody>
-          <a:bodyPr wrap="square" rtlCol="0" anchor="t"/>
-          <a:lstStyle/>
-          <a:p>
-            <a:pPr algn="ctr" indent="0" marL="0">
-              <a:buNone/>
-            </a:pPr>
-            <a:r>
-              <a:rPr lang="en-US" sz="1100" dirty="0">
-                <a:solidFill>
-                  <a:srgbClr val="94A3B8"/>
-                </a:solidFill>
-                <a:latin typeface="Calibri" pitchFamily="34" charset="0"/>
-                <a:ea typeface="Calibri" pitchFamily="34" charset="-122"/>
-                <a:cs typeface="Calibri" pitchFamily="34" charset="-120"/>
-              </a:rPr>
-              <a:t>Türkiye için</a:t>
-            </a:r>
-            <a:endParaRPr lang="en-US" sz="1100" dirty="0"/>
-          </a:p>
-        </p:txBody>
-      </p:sp>
-      <p:sp>
-        <p:nvSpPr>
-          <p:cNvPr id="31" name="Shape 29"/>
-          <p:cNvSpPr/>
-          <p:nvPr/>
-        </p:nvSpPr>
-        <p:spPr>
-          <a:xfrm>
-            <a:off x="548640" y="5120640"/>
-            <a:ext cx="11064240" cy="1097280"/>
-          </a:xfrm>
-          <a:prstGeom prst="rect">
-            <a:avLst/>
-          </a:prstGeom>
-          <a:solidFill>
-            <a:srgbClr val="0F1424"/>
-          </a:solidFill>
-          <a:ln w="9525">
-            <a:solidFill>
-              <a:srgbClr val="1E293B"/>
-            </a:solidFill>
-            <a:prstDash val="solid"/>
-          </a:ln>
-        </p:spPr>
-      </p:sp>
-      <p:sp>
-        <p:nvSpPr>
-          <p:cNvPr id="32" name="Shape 30"/>
-          <p:cNvSpPr/>
-          <p:nvPr/>
-        </p:nvSpPr>
-        <p:spPr>
-          <a:xfrm>
-            <a:off x="548640" y="5120640"/>
-            <a:ext cx="54864" cy="1097280"/>
-          </a:xfrm>
-          <a:prstGeom prst="rect">
-            <a:avLst/>
-          </a:prstGeom>
-          <a:solidFill>
-            <a:srgbClr val="34D399"/>
-          </a:solidFill>
-          <a:ln w="12700">
-            <a:solidFill>
-              <a:srgbClr val="34D399"/>
-            </a:solidFill>
-            <a:prstDash val="solid"/>
-          </a:ln>
-        </p:spPr>
-      </p:sp>
-      <p:sp>
-        <p:nvSpPr>
-          <p:cNvPr id="33" name="Text 31"/>
-          <p:cNvSpPr/>
-          <p:nvPr/>
-        </p:nvSpPr>
-        <p:spPr>
-          <a:xfrm>
-            <a:off x="777240" y="5257800"/>
-            <a:ext cx="10607040" cy="822960"/>
-          </a:xfrm>
-          <a:prstGeom prst="rect">
-            <a:avLst/>
-          </a:prstGeom>
-          <a:noFill/>
-          <a:ln/>
-        </p:spPr>
-        <p:txBody>
-          <a:bodyPr wrap="square" rtlCol="0" anchor="ctr"/>
-          <a:lstStyle/>
-          <a:p>
-            <a:pPr algn="l" indent="0" marL="0">
-              <a:buNone/>
-            </a:pPr>
-            <a:r>
-              <a:rPr lang="en-US" sz="1500" dirty="0">
-                <a:solidFill>
-                  <a:srgbClr val="94A3B8"/>
-                </a:solidFill>
-                <a:latin typeface="Calibri" pitchFamily="34" charset="0"/>
-                <a:ea typeface="Calibri" pitchFamily="34" charset="-122"/>
-                <a:cs typeface="Calibri" pitchFamily="34" charset="-120"/>
-              </a:rPr>
-              <a:t>Slayttaki tüm gereklilikleri karşıladık. </a:t>
-            </a:r>
-            <a:pPr algn="l" indent="0" marL="0">
-              <a:buNone/>
-            </a:pPr>
-            <a:r>
-              <a:rPr lang="en-US" sz="1500" b="1" dirty="0">
-                <a:solidFill>
-                  <a:srgbClr val="E6EAF2"/>
-                </a:solidFill>
-                <a:latin typeface="Calibri" pitchFamily="34" charset="0"/>
-                <a:ea typeface="Calibri" pitchFamily="34" charset="-122"/>
-                <a:cs typeface="Calibri" pitchFamily="34" charset="-120"/>
-              </a:rPr>
-              <a:t>Gemini ana ürün, LangGraph orkestrasyon, A2A çoklu-ajan protokolü.
-</a:t>
-            </a:r>
-            <a:endParaRPr lang="en-US" sz="1500" dirty="0"/>
-          </a:p>
-          <a:p>
-            <a:pPr algn="l" indent="0" marL="0">
-              <a:buNone/>
-            </a:pPr>
-            <a:r>
-              <a:rPr lang="en-US" sz="1700" b="1" i="1" dirty="0">
-                <a:solidFill>
-                  <a:srgbClr val="34D399"/>
-                </a:solidFill>
-                <a:latin typeface="Calibri" pitchFamily="34" charset="0"/>
-                <a:ea typeface="Calibri" pitchFamily="34" charset="-122"/>
-                <a:cs typeface="Calibri" pitchFamily="34" charset="-120"/>
-              </a:rPr>
-              <a:t>Üretime hazır mimari. Hackathon zamanı geldi.</a:t>
-            </a:r>
-            <a:endParaRPr lang="en-US" sz="1500" dirty="0"/>
-          </a:p>
-        </p:txBody>
-      </p:sp>
-      <p:sp>
-        <p:nvSpPr>
-          <p:cNvPr id="34" name="Text 32"/>
-          <p:cNvSpPr/>
-          <p:nvPr/>
-        </p:nvSpPr>
-        <p:spPr>
-          <a:xfrm>
-            <a:off x="11430000" y="6446520"/>
-            <a:ext cx="640080" cy="274320"/>
-          </a:xfrm>
-          <a:prstGeom prst="rect">
-            <a:avLst/>
-          </a:prstGeom>
-          <a:noFill/>
-          <a:ln/>
-        </p:spPr>
-        <p:txBody>
-          <a:bodyPr wrap="square" rtlCol="0" anchor="ctr"/>
-          <a:lstStyle/>
-          <a:p>
-            <a:pPr algn="r" indent="0" marL="0">
-              <a:buNone/>
-            </a:pPr>
-            <a:r>
-              <a:rPr lang="en-US" sz="900" dirty="0">
-                <a:solidFill>
-                  <a:srgbClr val="64748B"/>
-                </a:solidFill>
-                <a:latin typeface="Calibri" pitchFamily="34" charset="0"/>
-                <a:ea typeface="Calibri" pitchFamily="34" charset="-122"/>
-                <a:cs typeface="Calibri" pitchFamily="34" charset="-120"/>
-              </a:rPr>
-              <a:t>06 / 6</a:t>
-            </a:r>
-            <a:endParaRPr lang="en-US" sz="900" dirty="0"/>
-          </a:p>
-        </p:txBody>
-      </p:sp>
-      <p:sp>
-        <p:nvSpPr>
-          <p:cNvPr id="35" name="Text 33"/>
           <p:cNvSpPr/>
           <p:nvPr/>
         </p:nvSpPr>

</xml_diff>